<commit_message>
Improve report UI and dynamic PPT slide rendering
</commit_message>
<xml_diff>
--- a/backend/Campaign_Report_PyroMedia.pptx
+++ b/backend/Campaign_Report_PyroMedia.pptx
@@ -6637,8 +6637,8 @@
         </p:nvSpPr>
         <p:spPr>
           <a:xfrm>
-            <a:off x="3465899" y="1816300"/>
-            <a:ext cx="2817669" cy="1000500"/>
+            <a:off x="3140000" y="1660000"/>
+            <a:ext cx="3480000" cy="980000"/>
           </a:xfrm>
           <a:prstGeom prst="rect">
             <a:avLst/>
@@ -6650,11 +6650,14 @@
         </p:spPr>
         <p:txBody>
           <a:bodyPr spcFirstLastPara="1" wrap="square" lIns="91425" tIns="91425" rIns="91425" bIns="91425" anchor="t" anchorCtr="0">
-            <a:spAutoFit/>
+            <a:normAutofit/>
           </a:bodyPr>
           <a:lstStyle/>
           <a:p>
-            <a:pPr marL="0" lvl="0" indent="0" algn="l" rtl="0">
+            <a:pPr marL="0" lvl="0" indent="0" algn="ctr" rtl="0">
+              <a:lnSpc>
+                <a:spcPct val="92000"/>
+              </a:lnSpc>
               <a:spcBef>
                 <a:spcPts val="0"/>
               </a:spcBef>
@@ -6664,16 +6667,13 @@
               <a:buNone/>
             </a:pPr>
             <a:r>
-              <a:rPr lang="en" sz="5300" b="1" i="1">
+              <a:rPr sz="4100" b="1" i="1">
                 <a:solidFill>
                   <a:srgbClr val="2B3E5C"/>
                 </a:solidFill>
                 <a:latin typeface="YouTube Sans"/>
-                <a:ea typeface="YouTube Sans"/>
-                <a:cs typeface="YouTube Sans"/>
-                <a:sym typeface="YouTube Sans"/>
               </a:rPr>
-              <a:t>Report </a:t>
+              <a:t>Campaign Report</a:t>
             </a:r>
             <a:endParaRPr sz="5300" b="1" i="1">
               <a:solidFill>
@@ -6691,8 +6691,8 @@
         </p:nvSpPr>
         <p:spPr>
           <a:xfrm>
-            <a:off x="2271450" y="2773075"/>
-            <a:ext cx="5043750" cy="554100"/>
+            <a:off x="2050000" y="2865000"/>
+            <a:ext cx="5500000" cy="360000"/>
           </a:xfrm>
           <a:prstGeom prst="rect">
             <a:avLst/>
@@ -6704,11 +6704,14 @@
         </p:spPr>
         <p:txBody>
           <a:bodyPr spcFirstLastPara="1" wrap="square" lIns="91425" tIns="91425" rIns="91425" bIns="91425" anchor="t" anchorCtr="0">
-            <a:spAutoFit/>
+            <a:normAutofit/>
           </a:bodyPr>
           <a:lstStyle/>
           <a:p>
-            <a:pPr marL="0" lvl="0" indent="0" algn="l" rtl="0">
+            <a:pPr marL="0" lvl="0" indent="0" algn="ctr" rtl="0">
+              <a:lnSpc>
+                <a:spcPct val="100000"/>
+              </a:lnSpc>
               <a:spcBef>
                 <a:spcPts val="0"/>
               </a:spcBef>
@@ -6718,16 +6721,13 @@
               <a:buNone/>
             </a:pPr>
             <a:r>
-              <a:rPr lang="en" sz="2400" dirty="0">
+              <a:rPr sz="2100" b="0" i="0">
                 <a:solidFill>
-                  <a:srgbClr val="000000"/>
+                  <a:srgbClr val="555F73"/>
                 </a:solidFill>
-                <a:latin typeface="YouTube Sans"/>
-                <a:ea typeface="YouTube Sans"/>
-                <a:cs typeface="YouTube Sans"/>
-                <a:sym typeface="YouTube Sans"/>
+                <a:latin typeface="Aptos"/>
               </a:rPr>
-              <a:t>Never let your effort missed out 😤</a:t>
+              <a:t>Making every campaign effort count.</a:t>
             </a:r>
             <a:endParaRPr sz="2400" dirty="0">
               <a:solidFill>
@@ -7086,8 +7086,8 @@
         </p:nvSpPr>
         <p:spPr>
           <a:xfrm>
-            <a:off x="311700" y="1256538"/>
-            <a:ext cx="3000000" cy="2630400"/>
+            <a:off x="311700" y="1190000"/>
+            <a:ext cx="3100000" cy="2850000"/>
           </a:xfrm>
           <a:prstGeom prst="rect">
             <a:avLst/>
@@ -7099,188 +7099,30 @@
         </p:spPr>
         <p:txBody>
           <a:bodyPr spcFirstLastPara="1" wrap="square" lIns="91425" tIns="91425" rIns="91425" bIns="91425" anchor="t" anchorCtr="0">
-            <a:spAutoFit/>
+            <a:normAutofit/>
           </a:bodyPr>
           <a:lstStyle/>
           <a:p>
             <a:pPr marL="0" lvl="0" indent="0" algn="l" rtl="0">
               <a:lnSpc>
-                <a:spcPct val="115000"/>
+                <a:spcPct val="105000"/>
               </a:lnSpc>
               <a:spcBef>
-                <a:spcPts val="1200"/>
-              </a:spcBef>
-              <a:spcAft>
-                <a:spcPts val="1700"/>
+                <a:spcPts val="0"/>
+              </a:spcBef>
+              <a:spcAft>
+                <a:spcPts val="0"/>
               </a:spcAft>
               <a:buNone/>
             </a:pPr>
             <a:r>
-              <a:rPr lang="en" b="1">
+              <a:rPr sz="1800" b="1" i="0">
                 <a:solidFill>
-                  <a:srgbClr val="000000"/>
+                  <a:srgbClr val="2B3E5C"/>
                 </a:solidFill>
+                <a:latin typeface="Aptos"/>
               </a:rPr>
-              <a:t>No. of Views: </a:t>
-            </a:r>
-            <a:br>
-              <a:rPr lang="en">
-                <a:solidFill>
-                  <a:srgbClr val="000000"/>
-                </a:solidFill>
-              </a:rPr>
-            </a:br>
-            <a:r>
-              <a:rPr lang="en" b="1">
-                <a:solidFill>
-                  <a:srgbClr val="000000"/>
-                </a:solidFill>
-              </a:rPr>
-              <a:t>Likes:</a:t>
-            </a:r>
-            <a:br>
-              <a:rPr lang="en">
-                <a:solidFill>
-                  <a:srgbClr val="000000"/>
-                </a:solidFill>
-              </a:rPr>
-            </a:br>
-            <a:r>
-              <a:rPr lang="en" b="1">
-                <a:solidFill>
-                  <a:srgbClr val="000000"/>
-                </a:solidFill>
-              </a:rPr>
-              <a:t>Shares: </a:t>
-            </a:r>
-            <a:br>
-              <a:rPr lang="en">
-                <a:solidFill>
-                  <a:srgbClr val="000000"/>
-                </a:solidFill>
-              </a:rPr>
-            </a:br>
-            <a:r>
-              <a:rPr lang="en" b="1">
-                <a:solidFill>
-                  <a:srgbClr val="000000"/>
-                </a:solidFill>
-              </a:rPr>
-              <a:t>Saves:</a:t>
-            </a:r>
-            <a:r>
-              <a:rPr lang="en">
-                <a:solidFill>
-                  <a:srgbClr val="000000"/>
-                </a:solidFill>
-              </a:rPr>
-              <a:t> </a:t>
-            </a:r>
-            <a:br>
-              <a:rPr lang="en">
-                <a:solidFill>
-                  <a:srgbClr val="000000"/>
-                </a:solidFill>
-              </a:rPr>
-            </a:br>
-            <a:r>
-              <a:rPr lang="en" b="1">
-                <a:solidFill>
-                  <a:srgbClr val="000000"/>
-                </a:solidFill>
-              </a:rPr>
-              <a:t>Total Engagement: </a:t>
-            </a:r>
-            <a:br>
-              <a:rPr lang="en">
-                <a:solidFill>
-                  <a:srgbClr val="000000"/>
-                </a:solidFill>
-              </a:rPr>
-            </a:br>
-            <a:r>
-              <a:rPr lang="en" b="1">
-                <a:solidFill>
-                  <a:srgbClr val="000000"/>
-                </a:solidFill>
-              </a:rPr>
-              <a:t>Budget:</a:t>
-            </a:r>
-            <a:r>
-              <a:rPr lang="en">
-                <a:solidFill>
-                  <a:srgbClr val="000000"/>
-                </a:solidFill>
-              </a:rPr>
-              <a:t> </a:t>
-            </a:r>
-            <a:br>
-              <a:rPr lang="en">
-                <a:solidFill>
-                  <a:srgbClr val="000000"/>
-                </a:solidFill>
-              </a:rPr>
-            </a:br>
-            <a:r>
-              <a:rPr lang="en" b="1">
-                <a:solidFill>
-                  <a:srgbClr val="000000"/>
-                </a:solidFill>
-              </a:rPr>
-              <a:t>CPV:</a:t>
-            </a:r>
-            <a:r>
-              <a:rPr lang="en">
-                <a:solidFill>
-                  <a:srgbClr val="000000"/>
-                </a:solidFill>
-              </a:rPr>
-              <a:t> </a:t>
-            </a:r>
-            <a:br>
-              <a:rPr lang="en">
-                <a:solidFill>
-                  <a:srgbClr val="000000"/>
-                </a:solidFill>
-              </a:rPr>
-            </a:br>
-            <a:r>
-              <a:rPr lang="en" b="1">
-                <a:solidFill>
-                  <a:srgbClr val="000000"/>
-                </a:solidFill>
-              </a:rPr>
-              <a:t>CPE:</a:t>
-            </a:r>
-            <a:r>
-              <a:rPr lang="en">
-                <a:solidFill>
-                  <a:srgbClr val="000000"/>
-                </a:solidFill>
-              </a:rPr>
-              <a:t> </a:t>
-            </a:r>
-            <a:br>
-              <a:rPr lang="en">
-                <a:solidFill>
-                  <a:srgbClr val="000000"/>
-                </a:solidFill>
-              </a:rPr>
-            </a:br>
-            <a:br>
-              <a:rPr lang="en">
-                <a:solidFill>
-                  <a:srgbClr val="000000"/>
-                </a:solidFill>
-              </a:rPr>
-            </a:br>
-            <a:r>
-              <a:rPr lang="en" b="1">
-                <a:solidFill>
-                  <a:srgbClr val="000000"/>
-                </a:solidFill>
-              </a:rPr>
-              <a:t>Learnings:</a:t>
+              <a:t>No. of Views:_x000B_Likes:_x000B_Shares:_x000B_Saves:_x000B_Total Engagement:_x000B_Budget:_x000B_CPC:_x000B_CPV:_x000B_CPE:_x000B__x000B_Learnings:</a:t>
             </a:r>
             <a:endParaRPr b="1">
               <a:solidFill>
@@ -7298,8 +7140,8 @@
         </p:nvSpPr>
         <p:spPr>
           <a:xfrm>
-            <a:off x="4776625" y="3886950"/>
-            <a:ext cx="2518200" cy="338700"/>
+            <a:off x="4776625" y="3950000"/>
+            <a:ext cx="2600000" cy="338700"/>
           </a:xfrm>
           <a:prstGeom prst="rect">
             <a:avLst/>
@@ -7311,11 +7153,14 @@
         </p:spPr>
         <p:txBody>
           <a:bodyPr spcFirstLastPara="1" wrap="square" lIns="91425" tIns="91425" rIns="91425" bIns="91425" anchor="t" anchorCtr="0">
-            <a:spAutoFit/>
+            <a:normAutofit/>
           </a:bodyPr>
           <a:lstStyle/>
           <a:p>
-            <a:pPr marL="0" lvl="0" indent="0" algn="l" rtl="0">
+            <a:pPr marL="0" lvl="0" indent="0" algn="ctr" rtl="0">
+              <a:lnSpc>
+                <a:spcPct val="100000"/>
+              </a:lnSpc>
               <a:spcBef>
                 <a:spcPts val="0"/>
               </a:spcBef>
@@ -7325,12 +7170,13 @@
               <a:buNone/>
             </a:pPr>
             <a:r>
-              <a:rPr lang="en" sz="1000">
+              <a:rPr sz="1400" b="0" i="0">
                 <a:solidFill>
-                  <a:schemeClr val="dk2"/>
+                  <a:srgbClr val="737B8C"/>
                 </a:solidFill>
+                <a:latin typeface="Aptos"/>
               </a:rPr>
-              <a:t>Campaign Photos Here at Least 3 photos</a:t>
+              <a:t>Campaign performance gallery</a:t>
             </a:r>
             <a:endParaRPr sz="1000">
               <a:solidFill>
@@ -7722,11 +7568,14 @@
         </p:spPr>
         <p:txBody>
           <a:bodyPr spcFirstLastPara="1" wrap="square" lIns="91425" tIns="91425" rIns="91425" bIns="91425" anchor="t" anchorCtr="0">
-            <a:spAutoFit/>
+            <a:normAutofit/>
           </a:bodyPr>
           <a:lstStyle/>
           <a:p>
             <a:pPr marL="0" lvl="0" indent="0" algn="l" rtl="0">
+              <a:lnSpc>
+                <a:spcPct val="95000"/>
+              </a:lnSpc>
               <a:spcBef>
                 <a:spcPts val="0"/>
               </a:spcBef>
@@ -7736,16 +7585,13 @@
               <a:buNone/>
             </a:pPr>
             <a:r>
-              <a:rPr lang="en" sz="2500" b="1" i="1">
+              <a:rPr sz="2800" b="1" i="1">
                 <a:solidFill>
                   <a:srgbClr val="2B3E5C"/>
                 </a:solidFill>
                 <a:latin typeface="YouTube Sans"/>
-                <a:ea typeface="YouTube Sans"/>
-                <a:cs typeface="YouTube Sans"/>
-                <a:sym typeface="YouTube Sans"/>
               </a:rPr>
-              <a:t>Creator x Brand Name</a:t>
+              <a:t>Creator x Brand Overview</a:t>
             </a:r>
             <a:endParaRPr sz="2500" b="1" i="1">
               <a:solidFill>
@@ -7770,8 +7616,8 @@
         </p:nvSpPr>
         <p:spPr>
           <a:xfrm>
-            <a:off x="196725" y="1256550"/>
-            <a:ext cx="3000000" cy="2630400"/>
+            <a:off x="196725" y="1190000"/>
+            <a:ext cx="3100000" cy="2850000"/>
           </a:xfrm>
           <a:prstGeom prst="rect">
             <a:avLst/>
@@ -7783,188 +7629,30 @@
         </p:spPr>
         <p:txBody>
           <a:bodyPr spcFirstLastPara="1" wrap="square" lIns="91425" tIns="91425" rIns="91425" bIns="91425" anchor="t" anchorCtr="0">
-            <a:spAutoFit/>
+            <a:normAutofit/>
           </a:bodyPr>
           <a:lstStyle/>
           <a:p>
             <a:pPr marL="0" lvl="0" indent="0" algn="l" rtl="0">
               <a:lnSpc>
-                <a:spcPct val="115000"/>
+                <a:spcPct val="105000"/>
               </a:lnSpc>
               <a:spcBef>
-                <a:spcPts val="1200"/>
-              </a:spcBef>
-              <a:spcAft>
-                <a:spcPts val="1700"/>
+                <a:spcPts val="0"/>
+              </a:spcBef>
+              <a:spcAft>
+                <a:spcPts val="0"/>
               </a:spcAft>
               <a:buNone/>
             </a:pPr>
             <a:r>
-              <a:rPr lang="en" b="1">
+              <a:rPr sz="1800" b="1" i="0">
                 <a:solidFill>
-                  <a:schemeClr val="dk1"/>
+                  <a:srgbClr val="2B3E5C"/>
                 </a:solidFill>
+                <a:latin typeface="Aptos"/>
               </a:rPr>
-              <a:t>No. of Views: </a:t>
-            </a:r>
-            <a:br>
-              <a:rPr lang="en">
-                <a:solidFill>
-                  <a:schemeClr val="dk1"/>
-                </a:solidFill>
-              </a:rPr>
-            </a:br>
-            <a:r>
-              <a:rPr lang="en" b="1">
-                <a:solidFill>
-                  <a:schemeClr val="dk1"/>
-                </a:solidFill>
-              </a:rPr>
-              <a:t>Likes:</a:t>
-            </a:r>
-            <a:br>
-              <a:rPr lang="en">
-                <a:solidFill>
-                  <a:schemeClr val="dk1"/>
-                </a:solidFill>
-              </a:rPr>
-            </a:br>
-            <a:r>
-              <a:rPr lang="en" b="1">
-                <a:solidFill>
-                  <a:schemeClr val="dk1"/>
-                </a:solidFill>
-              </a:rPr>
-              <a:t>Shares: </a:t>
-            </a:r>
-            <a:br>
-              <a:rPr lang="en">
-                <a:solidFill>
-                  <a:schemeClr val="dk1"/>
-                </a:solidFill>
-              </a:rPr>
-            </a:br>
-            <a:r>
-              <a:rPr lang="en" b="1">
-                <a:solidFill>
-                  <a:schemeClr val="dk1"/>
-                </a:solidFill>
-              </a:rPr>
-              <a:t>Saves:</a:t>
-            </a:r>
-            <a:r>
-              <a:rPr lang="en">
-                <a:solidFill>
-                  <a:schemeClr val="dk1"/>
-                </a:solidFill>
-              </a:rPr>
-              <a:t> </a:t>
-            </a:r>
-            <a:br>
-              <a:rPr lang="en">
-                <a:solidFill>
-                  <a:schemeClr val="dk1"/>
-                </a:solidFill>
-              </a:rPr>
-            </a:br>
-            <a:r>
-              <a:rPr lang="en" b="1">
-                <a:solidFill>
-                  <a:schemeClr val="dk1"/>
-                </a:solidFill>
-              </a:rPr>
-              <a:t>Total Engagement: </a:t>
-            </a:r>
-            <a:br>
-              <a:rPr lang="en">
-                <a:solidFill>
-                  <a:schemeClr val="dk1"/>
-                </a:solidFill>
-              </a:rPr>
-            </a:br>
-            <a:r>
-              <a:rPr lang="en" b="1">
-                <a:solidFill>
-                  <a:schemeClr val="dk1"/>
-                </a:solidFill>
-              </a:rPr>
-              <a:t>Budget:</a:t>
-            </a:r>
-            <a:r>
-              <a:rPr lang="en">
-                <a:solidFill>
-                  <a:schemeClr val="dk1"/>
-                </a:solidFill>
-              </a:rPr>
-              <a:t> </a:t>
-            </a:r>
-            <a:br>
-              <a:rPr lang="en">
-                <a:solidFill>
-                  <a:schemeClr val="dk1"/>
-                </a:solidFill>
-              </a:rPr>
-            </a:br>
-            <a:r>
-              <a:rPr lang="en" b="1">
-                <a:solidFill>
-                  <a:schemeClr val="dk1"/>
-                </a:solidFill>
-              </a:rPr>
-              <a:t>CPV:</a:t>
-            </a:r>
-            <a:r>
-              <a:rPr lang="en">
-                <a:solidFill>
-                  <a:schemeClr val="dk1"/>
-                </a:solidFill>
-              </a:rPr>
-              <a:t> </a:t>
-            </a:r>
-            <a:br>
-              <a:rPr lang="en">
-                <a:solidFill>
-                  <a:schemeClr val="dk1"/>
-                </a:solidFill>
-              </a:rPr>
-            </a:br>
-            <a:r>
-              <a:rPr lang="en" b="1">
-                <a:solidFill>
-                  <a:schemeClr val="dk1"/>
-                </a:solidFill>
-              </a:rPr>
-              <a:t>CPE:</a:t>
-            </a:r>
-            <a:r>
-              <a:rPr lang="en">
-                <a:solidFill>
-                  <a:schemeClr val="dk1"/>
-                </a:solidFill>
-              </a:rPr>
-              <a:t> </a:t>
-            </a:r>
-            <a:br>
-              <a:rPr lang="en">
-                <a:solidFill>
-                  <a:schemeClr val="dk1"/>
-                </a:solidFill>
-              </a:rPr>
-            </a:br>
-            <a:br>
-              <a:rPr lang="en">
-                <a:solidFill>
-                  <a:schemeClr val="dk1"/>
-                </a:solidFill>
-              </a:rPr>
-            </a:br>
-            <a:r>
-              <a:rPr lang="en" b="1">
-                <a:solidFill>
-                  <a:schemeClr val="dk1"/>
-                </a:solidFill>
-              </a:rPr>
-              <a:t>Learnings:</a:t>
+              <a:t>No. of Views:_x000B_Likes:_x000B_Shares:_x000B_Saves:_x000B_Total Engagement:_x000B_Budget:_x000B_CPC:_x000B_CPV:_x000B_CPE:_x000B__x000B_Learnings:</a:t>
             </a:r>
             <a:endParaRPr b="1">
               <a:solidFill>
@@ -7995,11 +7683,14 @@
         </p:spPr>
         <p:txBody>
           <a:bodyPr spcFirstLastPara="1" wrap="square" lIns="91425" tIns="91425" rIns="91425" bIns="91425" anchor="t" anchorCtr="0">
-            <a:spAutoFit/>
+            <a:normAutofit/>
           </a:bodyPr>
           <a:lstStyle/>
           <a:p>
-            <a:pPr marL="0" lvl="0" indent="0" algn="l" rtl="0">
+            <a:pPr marL="0" lvl="0" indent="0" algn="ctr" rtl="0">
+              <a:lnSpc>
+                <a:spcPct val="100000"/>
+              </a:lnSpc>
               <a:spcBef>
                 <a:spcPts val="0"/>
               </a:spcBef>
@@ -8009,12 +7700,13 @@
               <a:buNone/>
             </a:pPr>
             <a:r>
-              <a:rPr lang="en" sz="1000">
+              <a:rPr sz="1400" b="0" i="0">
                 <a:solidFill>
-                  <a:schemeClr val="dk2"/>
+                  <a:srgbClr val="737B8C"/>
                 </a:solidFill>
+                <a:latin typeface="Aptos"/>
               </a:rPr>
-              <a:t>Creator content picture here</a:t>
+              <a:t>Creator content snapshot</a:t>
             </a:r>
             <a:endParaRPr sz="1000">
               <a:solidFill>
@@ -8032,8 +7724,8 @@
         </p:nvSpPr>
         <p:spPr>
           <a:xfrm>
-            <a:off x="6815100" y="1827200"/>
-            <a:ext cx="1823400" cy="800400"/>
+            <a:off x="6815100" y="2050000"/>
+            <a:ext cx="1823400" cy="700000"/>
           </a:xfrm>
           <a:prstGeom prst="rect">
             <a:avLst/>
@@ -8045,11 +7737,14 @@
         </p:spPr>
         <p:txBody>
           <a:bodyPr spcFirstLastPara="1" wrap="square" lIns="91425" tIns="91425" rIns="91425" bIns="91425" anchor="t" anchorCtr="0">
-            <a:spAutoFit/>
+            <a:normAutofit/>
           </a:bodyPr>
           <a:lstStyle/>
           <a:p>
             <a:pPr marL="0" lvl="0" indent="0" algn="l" rtl="0">
+              <a:lnSpc>
+                <a:spcPct val="105000"/>
+              </a:lnSpc>
               <a:spcBef>
                 <a:spcPts val="0"/>
               </a:spcBef>
@@ -8059,12 +7754,14 @@
               <a:buNone/>
             </a:pPr>
             <a:r>
-              <a:rPr lang="en" sz="1000">
+              <a:rPr sz="1300" b="0" i="0">
                 <a:solidFill>
-                  <a:schemeClr val="dk2"/>
+                  <a:srgbClr val="737B8C"/>
                 </a:solidFill>
+                <a:latin typeface="Aptos"/>
               </a:rPr>
-              <a:t>Creator’s content insights here. Only Insight from YouTube or Instagram dashboard.</a:t>
+              <a:t>Platform insights
+Instagram or YouTube analytics</a:t>
             </a:r>
             <a:endParaRPr sz="1000">
               <a:solidFill>
@@ -8213,64 +7910,6 @@
           </a:ln>
         </p:spPr>
       </p:pic>
-      <p:sp>
-        <p:nvSpPr>
-          <p:cNvPr id="106" name="Google Shape;106;p18"/>
-          <p:cNvSpPr txBox="1"/>
-          <p:nvPr/>
-        </p:nvSpPr>
-        <p:spPr>
-          <a:xfrm>
-            <a:off x="833275" y="4614800"/>
-            <a:ext cx="1823400" cy="336300"/>
-          </a:xfrm>
-          <a:prstGeom prst="rect">
-            <a:avLst/>
-          </a:prstGeom>
-          <a:noFill/>
-          <a:ln>
-            <a:noFill/>
-          </a:ln>
-        </p:spPr>
-        <p:txBody>
-          <a:bodyPr spcFirstLastPara="1" wrap="square" lIns="91425" tIns="91425" rIns="91425" bIns="91425" anchor="t" anchorCtr="0">
-            <a:noAutofit/>
-          </a:bodyPr>
-          <a:lstStyle/>
-          <a:p>
-            <a:pPr marL="0" lvl="0" indent="0" algn="l" rtl="0">
-              <a:spcBef>
-                <a:spcPts val="0"/>
-              </a:spcBef>
-              <a:spcAft>
-                <a:spcPts val="0"/>
-              </a:spcAft>
-              <a:buNone/>
-            </a:pPr>
-            <a:r>
-              <a:rPr lang="en" sz="900">
-                <a:solidFill>
-                  <a:srgbClr val="595959"/>
-                </a:solidFill>
-                <a:latin typeface="Poppins"/>
-                <a:ea typeface="Poppins"/>
-                <a:cs typeface="Poppins"/>
-                <a:sym typeface="Poppins"/>
-              </a:rPr>
-              <a:t>|  Confidential &amp; proprietary </a:t>
-            </a:r>
-            <a:endParaRPr sz="900">
-              <a:solidFill>
-                <a:srgbClr val="595959"/>
-              </a:solidFill>
-              <a:latin typeface="Poppins"/>
-              <a:ea typeface="Poppins"/>
-              <a:cs typeface="Poppins"/>
-              <a:sym typeface="Poppins"/>
-            </a:endParaRPr>
-          </a:p>
-        </p:txBody>
-      </p:sp>
       <p:pic>
         <p:nvPicPr>
           <p:cNvPr id="107" name="Google Shape;107;p18"/>
@@ -8299,64 +7938,6 @@
           </a:ln>
         </p:spPr>
       </p:pic>
-      <p:sp>
-        <p:nvSpPr>
-          <p:cNvPr id="108" name="Google Shape;108;p18"/>
-          <p:cNvSpPr txBox="1"/>
-          <p:nvPr/>
-        </p:nvSpPr>
-        <p:spPr>
-          <a:xfrm>
-            <a:off x="833275" y="4614800"/>
-            <a:ext cx="1823400" cy="336300"/>
-          </a:xfrm>
-          <a:prstGeom prst="rect">
-            <a:avLst/>
-          </a:prstGeom>
-          <a:noFill/>
-          <a:ln>
-            <a:noFill/>
-          </a:ln>
-        </p:spPr>
-        <p:txBody>
-          <a:bodyPr spcFirstLastPara="1" wrap="square" lIns="91425" tIns="91425" rIns="91425" bIns="91425" anchor="t" anchorCtr="0">
-            <a:noAutofit/>
-          </a:bodyPr>
-          <a:lstStyle/>
-          <a:p>
-            <a:pPr marL="0" lvl="0" indent="0" algn="l" rtl="0">
-              <a:spcBef>
-                <a:spcPts val="0"/>
-              </a:spcBef>
-              <a:spcAft>
-                <a:spcPts val="0"/>
-              </a:spcAft>
-              <a:buNone/>
-            </a:pPr>
-            <a:r>
-              <a:rPr lang="en" sz="900">
-                <a:solidFill>
-                  <a:srgbClr val="595959"/>
-                </a:solidFill>
-                <a:latin typeface="Poppins"/>
-                <a:ea typeface="Poppins"/>
-                <a:cs typeface="Poppins"/>
-                <a:sym typeface="Poppins"/>
-              </a:rPr>
-              <a:t>|  Confidential &amp; proprietary </a:t>
-            </a:r>
-            <a:endParaRPr sz="900">
-              <a:solidFill>
-                <a:srgbClr val="595959"/>
-              </a:solidFill>
-              <a:latin typeface="Poppins"/>
-              <a:ea typeface="Poppins"/>
-              <a:cs typeface="Poppins"/>
-              <a:sym typeface="Poppins"/>
-            </a:endParaRPr>
-          </a:p>
-        </p:txBody>
-      </p:sp>
       <p:pic>
         <p:nvPicPr>
           <p:cNvPr id="109" name="Google Shape;109;p18"/>
@@ -8385,64 +7966,6 @@
           </a:ln>
         </p:spPr>
       </p:pic>
-      <p:sp>
-        <p:nvSpPr>
-          <p:cNvPr id="110" name="Google Shape;110;p18"/>
-          <p:cNvSpPr txBox="1"/>
-          <p:nvPr/>
-        </p:nvSpPr>
-        <p:spPr>
-          <a:xfrm>
-            <a:off x="833275" y="4614800"/>
-            <a:ext cx="1823400" cy="336300"/>
-          </a:xfrm>
-          <a:prstGeom prst="rect">
-            <a:avLst/>
-          </a:prstGeom>
-          <a:noFill/>
-          <a:ln>
-            <a:noFill/>
-          </a:ln>
-        </p:spPr>
-        <p:txBody>
-          <a:bodyPr spcFirstLastPara="1" wrap="square" lIns="91425" tIns="91425" rIns="91425" bIns="91425" anchor="t" anchorCtr="0">
-            <a:noAutofit/>
-          </a:bodyPr>
-          <a:lstStyle/>
-          <a:p>
-            <a:pPr marL="0" lvl="0" indent="0" algn="l" rtl="0">
-              <a:spcBef>
-                <a:spcPts val="0"/>
-              </a:spcBef>
-              <a:spcAft>
-                <a:spcPts val="0"/>
-              </a:spcAft>
-              <a:buNone/>
-            </a:pPr>
-            <a:r>
-              <a:rPr lang="en" sz="900">
-                <a:solidFill>
-                  <a:srgbClr val="595959"/>
-                </a:solidFill>
-                <a:latin typeface="Poppins"/>
-                <a:ea typeface="Poppins"/>
-                <a:cs typeface="Poppins"/>
-                <a:sym typeface="Poppins"/>
-              </a:rPr>
-              <a:t>|  Confidential &amp; proprietary </a:t>
-            </a:r>
-            <a:endParaRPr sz="900">
-              <a:solidFill>
-                <a:srgbClr val="595959"/>
-              </a:solidFill>
-              <a:latin typeface="Poppins"/>
-              <a:ea typeface="Poppins"/>
-              <a:cs typeface="Poppins"/>
-              <a:sym typeface="Poppins"/>
-            </a:endParaRPr>
-          </a:p>
-        </p:txBody>
-      </p:sp>
       <p:pic>
         <p:nvPicPr>
           <p:cNvPr id="111" name="Google Shape;111;p18"/>
@@ -8471,64 +7994,6 @@
           </a:ln>
         </p:spPr>
       </p:pic>
-      <p:sp>
-        <p:nvSpPr>
-          <p:cNvPr id="112" name="Google Shape;112;p18"/>
-          <p:cNvSpPr txBox="1"/>
-          <p:nvPr/>
-        </p:nvSpPr>
-        <p:spPr>
-          <a:xfrm>
-            <a:off x="833275" y="4614800"/>
-            <a:ext cx="1823400" cy="336300"/>
-          </a:xfrm>
-          <a:prstGeom prst="rect">
-            <a:avLst/>
-          </a:prstGeom>
-          <a:noFill/>
-          <a:ln>
-            <a:noFill/>
-          </a:ln>
-        </p:spPr>
-        <p:txBody>
-          <a:bodyPr spcFirstLastPara="1" wrap="square" lIns="91425" tIns="91425" rIns="91425" bIns="91425" anchor="t" anchorCtr="0">
-            <a:noAutofit/>
-          </a:bodyPr>
-          <a:lstStyle/>
-          <a:p>
-            <a:pPr marL="0" lvl="0" indent="0" algn="l" rtl="0">
-              <a:spcBef>
-                <a:spcPts val="0"/>
-              </a:spcBef>
-              <a:spcAft>
-                <a:spcPts val="0"/>
-              </a:spcAft>
-              <a:buNone/>
-            </a:pPr>
-            <a:r>
-              <a:rPr lang="en" sz="900">
-                <a:solidFill>
-                  <a:srgbClr val="595959"/>
-                </a:solidFill>
-                <a:latin typeface="Poppins"/>
-                <a:ea typeface="Poppins"/>
-                <a:cs typeface="Poppins"/>
-                <a:sym typeface="Poppins"/>
-              </a:rPr>
-              <a:t>|  Confidential &amp; proprietary </a:t>
-            </a:r>
-            <a:endParaRPr sz="900">
-              <a:solidFill>
-                <a:srgbClr val="595959"/>
-              </a:solidFill>
-              <a:latin typeface="Poppins"/>
-              <a:ea typeface="Poppins"/>
-              <a:cs typeface="Poppins"/>
-              <a:sym typeface="Poppins"/>
-            </a:endParaRPr>
-          </a:p>
-        </p:txBody>
-      </p:sp>
       <p:pic>
         <p:nvPicPr>
           <p:cNvPr id="113" name="Google Shape;113;p18"/>
@@ -8565,8 +8030,8 @@
         </p:nvSpPr>
         <p:spPr>
           <a:xfrm>
-            <a:off x="1087799" y="738050"/>
-            <a:ext cx="7251216" cy="538800"/>
+            <a:off x="1100000" y="700000"/>
+            <a:ext cx="7000000" cy="538800"/>
           </a:xfrm>
           <a:prstGeom prst="rect">
             <a:avLst/>
@@ -8578,11 +8043,14 @@
         </p:spPr>
         <p:txBody>
           <a:bodyPr spcFirstLastPara="1" wrap="square" lIns="91425" tIns="91425" rIns="91425" bIns="91425" anchor="t" anchorCtr="0">
-            <a:spAutoFit/>
+            <a:normAutofit/>
           </a:bodyPr>
           <a:lstStyle/>
           <a:p>
-            <a:pPr marL="0" lvl="0" indent="0" algn="l" rtl="0">
+            <a:pPr marL="0" lvl="0" indent="0" algn="ctr" rtl="0">
+              <a:lnSpc>
+                <a:spcPct val="95000"/>
+              </a:lnSpc>
               <a:spcBef>
                 <a:spcPts val="0"/>
               </a:spcBef>
@@ -8592,13 +8060,13 @@
               <a:buNone/>
             </a:pPr>
             <a:r>
-              <a:rPr lang="en" sz="2300" b="1" i="1" dirty="0">
+              <a:rPr sz="2400" b="1" i="1">
+                <a:solidFill>
+                  <a:srgbClr val="2B3E5C"/>
+                </a:solidFill>
                 <a:latin typeface="YouTube Sans"/>
-                <a:ea typeface="YouTube Sans"/>
-                <a:cs typeface="YouTube Sans"/>
-                <a:sym typeface="YouTube Sans"/>
               </a:rPr>
-              <a:t>Clients who trust us for their marketing campaigns</a:t>
+              <a:t>Brands that trust us with standout campaigns</a:t>
             </a:r>
             <a:endParaRPr sz="2300" b="1" i="1" dirty="0">
               <a:solidFill>
@@ -8813,8 +8281,8 @@
         </p:nvSpPr>
         <p:spPr>
           <a:xfrm>
-            <a:off x="6678050" y="4005238"/>
-            <a:ext cx="1507800" cy="400200"/>
+            <a:off x="6400000" y="4040000"/>
+            <a:ext cx="2000000" cy="400200"/>
           </a:xfrm>
           <a:prstGeom prst="rect">
             <a:avLst/>
@@ -8826,11 +8294,14 @@
         </p:spPr>
         <p:txBody>
           <a:bodyPr spcFirstLastPara="1" wrap="square" lIns="91425" tIns="91425" rIns="91425" bIns="91425" anchor="t" anchorCtr="0">
-            <a:spAutoFit/>
+            <a:normAutofit/>
           </a:bodyPr>
           <a:lstStyle/>
           <a:p>
-            <a:pPr marL="0" lvl="0" indent="0" algn="l" rtl="0">
+            <a:pPr marL="0" lvl="0" indent="0" algn="r" rtl="0">
+              <a:lnSpc>
+                <a:spcPct val="100000"/>
+              </a:lnSpc>
               <a:spcBef>
                 <a:spcPts val="0"/>
               </a:spcBef>
@@ -8840,16 +8311,13 @@
               <a:buNone/>
             </a:pPr>
             <a:r>
-              <a:rPr lang="en">
+              <a:rPr sz="1800" b="0" i="0">
                 <a:solidFill>
-                  <a:srgbClr val="000000"/>
+                  <a:srgbClr val="555F73"/>
                 </a:solidFill>
-                <a:latin typeface="YouTube Sans"/>
-                <a:ea typeface="YouTube Sans"/>
-                <a:cs typeface="YouTube Sans"/>
-                <a:sym typeface="YouTube Sans"/>
+                <a:latin typeface="Aptos"/>
               </a:rPr>
-              <a:t>And many more….</a:t>
+              <a:t>And many more</a:t>
             </a:r>
             <a:endParaRPr>
               <a:solidFill>
@@ -9010,8 +8478,8 @@
         </p:nvSpPr>
         <p:spPr>
           <a:xfrm>
-            <a:off x="2552850" y="1448100"/>
-            <a:ext cx="4590412" cy="954300"/>
+            <a:off x="2700000" y="1448100"/>
+            <a:ext cx="3600000" cy="954300"/>
           </a:xfrm>
           <a:prstGeom prst="rect">
             <a:avLst/>
@@ -9023,11 +8491,14 @@
         </p:spPr>
         <p:txBody>
           <a:bodyPr spcFirstLastPara="1" wrap="square" lIns="91425" tIns="91425" rIns="91425" bIns="91425" anchor="t" anchorCtr="0">
-            <a:spAutoFit/>
+            <a:normAutofit/>
           </a:bodyPr>
           <a:lstStyle/>
           <a:p>
-            <a:pPr marL="0" lvl="0" indent="0" algn="l" rtl="0">
+            <a:pPr marL="0" lvl="0" indent="0" algn="ctr" rtl="0">
+              <a:lnSpc>
+                <a:spcPct val="100000"/>
+              </a:lnSpc>
               <a:spcBef>
                 <a:spcPts val="0"/>
               </a:spcBef>
@@ -9037,13 +8508,13 @@
               <a:buNone/>
             </a:pPr>
             <a:r>
-              <a:rPr lang="en" sz="5000" b="1" dirty="0">
+              <a:rPr sz="3800" b="1" i="0">
+                <a:solidFill>
+                  <a:srgbClr val="2B3E5C"/>
+                </a:solidFill>
                 <a:latin typeface="YouTube Sans"/>
-                <a:ea typeface="YouTube Sans"/>
-                <a:cs typeface="YouTube Sans"/>
-                <a:sym typeface="YouTube Sans"/>
               </a:rPr>
-              <a:t>Thank You 💚</a:t>
+              <a:t>Thank You</a:t>
             </a:r>
             <a:endParaRPr sz="5000" i="1" dirty="0">
               <a:solidFill>
@@ -9065,8 +8536,8 @@
         </p:nvSpPr>
         <p:spPr>
           <a:xfrm>
-            <a:off x="2324850" y="2402400"/>
-            <a:ext cx="5392500" cy="1293000"/>
+            <a:off x="2300000" y="2300000"/>
+            <a:ext cx="5600000" cy="1500000"/>
           </a:xfrm>
           <a:prstGeom prst="rect">
             <a:avLst/>
@@ -9078,116 +8549,39 @@
         </p:spPr>
         <p:txBody>
           <a:bodyPr spcFirstLastPara="1" wrap="square" lIns="91425" tIns="91425" rIns="91425" bIns="91425" anchor="t" anchorCtr="0">
-            <a:spAutoFit/>
+            <a:normAutofit/>
           </a:bodyPr>
           <a:lstStyle/>
           <a:p>
             <a:pPr marL="0" lvl="0" indent="0" algn="l" rtl="0">
-              <a:spcBef>
-                <a:spcPts val="0"/>
-              </a:spcBef>
-              <a:spcAft>
-                <a:spcPts val="0"/>
+              <a:lnSpc>
+                <a:spcPct val="108000"/>
+              </a:lnSpc>
+              <a:spcBef>
+                <a:spcPts val="0"/>
+              </a:spcBef>
+              <a:spcAft>
+                <a:spcPts val="400"/>
               </a:spcAft>
               <a:buNone/>
             </a:pPr>
             <a:r>
-              <a:rPr lang="en" sz="2400">
+              <a:rPr sz="2300" b="1">
                 <a:solidFill>
-                  <a:srgbClr val="000000"/>
+                  <a:srgbClr val="2B3E5C"/>
                 </a:solidFill>
-                <a:latin typeface="YouTube Sans"/>
-                <a:ea typeface="YouTube Sans"/>
-                <a:cs typeface="YouTube Sans"/>
-                <a:sym typeface="YouTube Sans"/>
+                <a:latin typeface="Aptos"/>
               </a:rPr>
               <a:t>Email: </a:t>
             </a:r>
             <a:r>
-              <a:rPr lang="en" sz="2400" u="sng">
+              <a:rPr sz="2300" b="0">
                 <a:solidFill>
-                  <a:srgbClr val="0097A7"/>
+                  <a:srgbClr val="0994B8"/>
                 </a:solidFill>
-                <a:latin typeface="YouTube Sans"/>
-                <a:ea typeface="YouTube Sans"/>
-                <a:cs typeface="YouTube Sans"/>
-                <a:sym typeface="YouTube Sans"/>
-                <a:hlinkClick r:id="rId4">
-                  <a:extLst>
-                    <a:ext uri="{A12FA001-AC4F-418D-AE19-62706E023703}">
-                      <ahyp:hlinkClr xmlns:ahyp="http://schemas.microsoft.com/office/drawing/2018/hyperlinkcolor" val="tx"/>
-                    </a:ext>
-                  </a:extLst>
-                </a:hlinkClick>
+                <a:latin typeface="Aptos"/>
               </a:rPr>
               <a:t>Kshitij@thepyromedia.com</a:t>
-            </a:r>
-            <a:br>
-              <a:rPr lang="en" sz="2400">
-                <a:solidFill>
-                  <a:srgbClr val="000000"/>
-                </a:solidFill>
-                <a:latin typeface="YouTube Sans"/>
-                <a:ea typeface="YouTube Sans"/>
-                <a:cs typeface="YouTube Sans"/>
-                <a:sym typeface="YouTube Sans"/>
-              </a:rPr>
-            </a:br>
-            <a:r>
-              <a:rPr lang="en" sz="2400">
-                <a:solidFill>
-                  <a:srgbClr val="000000"/>
-                </a:solidFill>
-                <a:latin typeface="YouTube Sans"/>
-                <a:ea typeface="YouTube Sans"/>
-                <a:cs typeface="YouTube Sans"/>
-                <a:sym typeface="YouTube Sans"/>
-              </a:rPr>
-              <a:t>Phone: +91 9315732227</a:t>
-            </a:r>
-            <a:br>
-              <a:rPr lang="en" sz="2400">
-                <a:solidFill>
-                  <a:srgbClr val="000000"/>
-                </a:solidFill>
-                <a:latin typeface="YouTube Sans"/>
-                <a:ea typeface="YouTube Sans"/>
-                <a:cs typeface="YouTube Sans"/>
-                <a:sym typeface="YouTube Sans"/>
-              </a:rPr>
-            </a:br>
-            <a:r>
-              <a:rPr lang="en" sz="2400">
-                <a:solidFill>
-                  <a:srgbClr val="000000"/>
-                </a:solidFill>
-                <a:latin typeface="YouTube Sans"/>
-                <a:ea typeface="YouTube Sans"/>
-                <a:cs typeface="YouTube Sans"/>
-                <a:sym typeface="YouTube Sans"/>
-              </a:rPr>
-              <a:t>Offices: Delhi</a:t>
-            </a:r>
-            <a:r>
-              <a:rPr lang="en" sz="2400">
-                <a:latin typeface="YouTube Sans"/>
-                <a:ea typeface="YouTube Sans"/>
-                <a:cs typeface="YouTube Sans"/>
-                <a:sym typeface="YouTube Sans"/>
-              </a:rPr>
-              <a:t>, Bangalore and</a:t>
-            </a:r>
-            <a:r>
-              <a:rPr lang="en" sz="2400">
-                <a:solidFill>
-                  <a:srgbClr val="000000"/>
-                </a:solidFill>
-                <a:latin typeface="YouTube Sans"/>
-                <a:ea typeface="YouTube Sans"/>
-                <a:cs typeface="YouTube Sans"/>
-                <a:sym typeface="YouTube Sans"/>
-              </a:rPr>
-              <a:t> Chandigarh</a:t>
             </a:r>
             <a:endParaRPr sz="2400">
               <a:solidFill>
@@ -9198,6 +8592,68 @@
               <a:cs typeface="YouTube Sans"/>
               <a:sym typeface="YouTube Sans"/>
             </a:endParaRPr>
+          </a:p>
+          <a:p>
+            <a:pPr algn="l">
+              <a:lnSpc>
+                <a:spcPct val="108000"/>
+              </a:lnSpc>
+              <a:spcBef>
+                <a:spcPts val="0"/>
+              </a:spcBef>
+              <a:spcAft>
+                <a:spcPts val="400"/>
+              </a:spcAft>
+            </a:pPr>
+            <a:r>
+              <a:rPr sz="2300" b="1">
+                <a:solidFill>
+                  <a:srgbClr val="2B3E5C"/>
+                </a:solidFill>
+                <a:latin typeface="Aptos"/>
+              </a:rPr>
+              <a:t>Phone: </a:t>
+            </a:r>
+            <a:r>
+              <a:rPr sz="2300" b="0">
+                <a:solidFill>
+                  <a:srgbClr val="555F73"/>
+                </a:solidFill>
+                <a:latin typeface="Aptos"/>
+              </a:rPr>
+              <a:t>+91 9315732227</a:t>
+            </a:r>
+          </a:p>
+          <a:p>
+            <a:pPr algn="l">
+              <a:lnSpc>
+                <a:spcPct val="108000"/>
+              </a:lnSpc>
+              <a:spcBef>
+                <a:spcPts val="0"/>
+              </a:spcBef>
+              <a:spcAft>
+                <a:spcPts val="400"/>
+              </a:spcAft>
+            </a:pPr>
+            <a:r>
+              <a:rPr sz="2300" b="1">
+                <a:solidFill>
+                  <a:srgbClr val="2B3E5C"/>
+                </a:solidFill>
+                <a:latin typeface="Aptos"/>
+              </a:rPr>
+              <a:t>Offices: </a:t>
+            </a:r>
+            <a:r>
+              <a:rPr sz="2300" b="0">
+                <a:solidFill>
+                  <a:srgbClr val="555F73"/>
+                </a:solidFill>
+                <a:latin typeface="Aptos"/>
+              </a:rPr>
+              <a:t>Delhi, Bangalore and Chandigarh</a:t>
+            </a:r>
           </a:p>
         </p:txBody>
       </p:sp>

</xml_diff>